<commit_message>
docs(presentation): refresh deck with the current corpus results
Numbers now reflect the rebuilt corpus and the measured shift: 179 586 chunks, vector nDCG@10 0.339 +/- 0.023, hybrid 0.301 +/- 0.017, reranker 0.117; routing 68 cases + 20-case blind set; metadata BM25 99.7%. Adds ADR 0008/0009 to the decision slide and updates the roadmap.
</commit_message>
<xml_diff>
--- a/docs/presentation/1c-mcp-rag-search-slides.pptx
+++ b/docs/presentation/1c-mcp-rag-search-slides.pptx
@@ -188,16 +188,16 @@
                 <c:formatCode>General</c:formatCode>
                 <c:ptCount val="4"/>
                 <c:pt idx="0">
-                  <c:v>0.176</c:v>
+                  <c:v>0.339</c:v>
                 </c:pt>
                 <c:pt idx="1">
-                  <c:v>0.194</c:v>
+                  <c:v>0.337</c:v>
                 </c:pt>
                 <c:pt idx="2">
-                  <c:v>0.209</c:v>
+                  <c:v>0.301</c:v>
                 </c:pt>
                 <c:pt idx="3">
-                  <c:v>0.069</c:v>
+                  <c:v>0.117</c:v>
                 </c:pt>
               </c:numCache>
             </c:numRef>
@@ -739,7 +739,7 @@
           <a:lstStyle/>
           <a:p>
             <a:r>
-              <a:t>Таблица и график. Hybrid выигрывает по nDCG, MRR и Recall; reranker проигрывает по всем метрикам.</a:t>
+              <a:t>Таблица и график по новому корпусу. Vector впереди; hybrid остаётся лучшим для exact-запросов; reranker проигрывает.</a:t>
             </a:r>
           </a:p>
         </p:txBody>
@@ -1019,7 +1019,7 @@
           <a:lstStyle/>
           <a:p>
             <a:r>
-              <a:t>Ключевые числа проекта. 124 тысячи чанков — полный индекс конфигурации: 100 445 чанков кода и 23 808 метаданных.</a:t>
+              <a:t>Ключевые числа проекта: 179 586 чанков — 154 560 кода (процедурная нарезка) и 25 026 метаданных (XML). Лидер на новом корпусе — vector (ADR 0009).</a:t>
             </a:r>
           </a:p>
         </p:txBody>
@@ -1159,7 +1159,7 @@
           <a:lstStyle/>
           <a:p>
             <a:r>
-              <a:t>Два независимых индекса: семантика и лексика. BM25 собирается отдельным скриптом, не входит в git и пересобирается за 9 секунд.</a:t>
+              <a:t>Два независимых индекса: семантика и лексика. BM25 собирается отдельным скриптом, не входит в git и пересобирается за 22 секунды.</a:t>
             </a:r>
           </a:p>
         </p:txBody>
@@ -1299,7 +1299,7 @@
           <a:lstStyle/>
           <a:p>
             <a:r>
-              <a:t>RRF — центральное решение проекта. Складываем не скоры, а позиции; поэтому не нужно подбирать веса. Прирост nDCG@10 почти 70 % при той же латентности.</a:t>
+              <a:t>RRF — центральное решение проекта. Складываем не скоры, а позиции; поэтому не нужно подбирать веса. На прежнем корпусе прирост был +19 %, на новом лидер сменился — это зафиксировано в ADR 0009.</a:t>
             </a:r>
           </a:p>
         </p:txBody>
@@ -5062,7 +5062,7 @@
                           </a:solidFill>
                           <a:latin typeface="Calibri"/>
                         </a:rPr>
-                        <a:t>0.076 ± 0.007</a:t>
+                        <a:t>0.150 ± 0.007</a:t>
                       </a:r>
                     </a:p>
                   </a:txBody>
@@ -5084,7 +5084,7 @@
                           </a:solidFill>
                           <a:latin typeface="Calibri"/>
                         </a:rPr>
-                        <a:t>0.127 ± 0.005</a:t>
+                        <a:t>0.268 ± 0.019</a:t>
                       </a:r>
                     </a:p>
                   </a:txBody>
@@ -5106,7 +5106,7 @@
                           </a:solidFill>
                           <a:latin typeface="Calibri"/>
                         </a:rPr>
-                        <a:t>0.176 ± 0.005</a:t>
+                        <a:t>0.339 ± 0.023</a:t>
                       </a:r>
                     </a:p>
                   </a:txBody>
@@ -5128,7 +5128,7 @@
                           </a:solidFill>
                           <a:latin typeface="Calibri"/>
                         </a:rPr>
-                        <a:t>0.310 ± 0.015</a:t>
+                        <a:t>0.523 ± 0.030</a:t>
                       </a:r>
                     </a:p>
                   </a:txBody>
@@ -5150,7 +5150,7 @@
                           </a:solidFill>
                           <a:latin typeface="Calibri"/>
                         </a:rPr>
-                        <a:t>~56</a:t>
+                        <a:t>~60</a:t>
                       </a:r>
                     </a:p>
                   </a:txBody>
@@ -5196,7 +5196,7 @@
                           </a:solidFill>
                           <a:latin typeface="Calibri"/>
                         </a:rPr>
-                        <a:t>0.090 ± 0.007</a:t>
+                        <a:t>0.179 ± 0.021</a:t>
                       </a:r>
                     </a:p>
                   </a:txBody>
@@ -5218,7 +5218,7 @@
                           </a:solidFill>
                           <a:latin typeface="Calibri"/>
                         </a:rPr>
-                        <a:t>0.139 ± 0.002</a:t>
+                        <a:t>0.270 ± 0.024</a:t>
                       </a:r>
                     </a:p>
                   </a:txBody>
@@ -5240,7 +5240,7 @@
                           </a:solidFill>
                           <a:latin typeface="Calibri"/>
                         </a:rPr>
-                        <a:t>0.194 ± 0.006</a:t>
+                        <a:t>0.337 ± 0.030</a:t>
                       </a:r>
                     </a:p>
                   </a:txBody>
@@ -5262,7 +5262,7 @@
                           </a:solidFill>
                           <a:latin typeface="Calibri"/>
                         </a:rPr>
-                        <a:t>0.348 ± 0.026</a:t>
+                        <a:t>0.511 ± 0.048</a:t>
                       </a:r>
                     </a:p>
                   </a:txBody>
@@ -5284,7 +5284,7 @@
                           </a:solidFill>
                           <a:latin typeface="Calibri"/>
                         </a:rPr>
-                        <a:t>~99</a:t>
+                        <a:t>~90</a:t>
                       </a:r>
                     </a:p>
                   </a:txBody>
@@ -5330,7 +5330,7 @@
                           </a:solidFill>
                           <a:latin typeface="Calibri"/>
                         </a:rPr>
-                        <a:t>0.090 ± 0.007</a:t>
+                        <a:t>0.129 ± 0.010</a:t>
                       </a:r>
                     </a:p>
                   </a:txBody>
@@ -5352,7 +5352,7 @@
                           </a:solidFill>
                           <a:latin typeface="Calibri"/>
                         </a:rPr>
-                        <a:t>0.158 ± 0.003</a:t>
+                        <a:t>0.240 ± 0.013</a:t>
                       </a:r>
                     </a:p>
                   </a:txBody>
@@ -5374,7 +5374,7 @@
                           </a:solidFill>
                           <a:latin typeface="Calibri"/>
                         </a:rPr>
-                        <a:t>0.209 ± 0.003</a:t>
+                        <a:t>0.301 ± 0.017</a:t>
                       </a:r>
                     </a:p>
                   </a:txBody>
@@ -5396,7 +5396,7 @@
                           </a:solidFill>
                           <a:latin typeface="Calibri"/>
                         </a:rPr>
-                        <a:t>0.352 ± 0.007</a:t>
+                        <a:t>0.482 ± 0.034</a:t>
                       </a:r>
                     </a:p>
                   </a:txBody>
@@ -5418,7 +5418,7 @@
                           </a:solidFill>
                           <a:latin typeface="Calibri"/>
                         </a:rPr>
-                        <a:t>~63</a:t>
+                        <a:t>~70</a:t>
                       </a:r>
                     </a:p>
                   </a:txBody>
@@ -5464,7 +5464,7 @@
                           </a:solidFill>
                           <a:latin typeface="Calibri"/>
                         </a:rPr>
-                        <a:t>0.014</a:t>
+                        <a:t>0.086</a:t>
                       </a:r>
                     </a:p>
                   </a:txBody>
@@ -5486,7 +5486,7 @@
                           </a:solidFill>
                           <a:latin typeface="Calibri"/>
                         </a:rPr>
-                        <a:t>0.047</a:t>
+                        <a:t>0.102</a:t>
                       </a:r>
                     </a:p>
                   </a:txBody>
@@ -5508,7 +5508,7 @@
                           </a:solidFill>
                           <a:latin typeface="Calibri"/>
                         </a:rPr>
-                        <a:t>0.069</a:t>
+                        <a:t>0.117</a:t>
                       </a:r>
                     </a:p>
                   </a:txBody>
@@ -5530,7 +5530,7 @@
                           </a:solidFill>
                           <a:latin typeface="Calibri"/>
                         </a:rPr>
-                        <a:t>0.136</a:t>
+                        <a:t>0.157</a:t>
                       </a:r>
                     </a:p>
                   </a:txBody>
@@ -5552,7 +5552,7 @@
                           </a:solidFill>
                           <a:latin typeface="Calibri"/>
                         </a:rPr>
-                        <a:t>~1100</a:t>
+                        <a:t>~2400</a:t>
                       </a:r>
                     </a:p>
                   </a:txBody>
@@ -5619,10 +5619,11 @@
                 </a:solidFill>
                 <a:latin typeface="Calibri"/>
               </a:rPr>
-              <a:t>Источник: data/eval/report_pipeline.md
-hybrid — дефолтный режим:
-лучший nDCG и MRR при минимальной латентности.
-Pearson-гибрид — только baseline.</a:t>
+              <a:t>Источник: data/eval/code_proc/report_pipeline.md
+vector — лидер на новом корпусе.
+hybrid лучший для exact-имён
+(0.408 против 0.250 по nDCG@10).
+Reranker ухудшает качество.</a:t>
             </a:r>
           </a:p>
         </p:txBody>
@@ -5991,84 +5992,6 @@
               <a:t>•  0007: нарезка по процедурам — устранён лимит 512 токенов</a:t>
             </a:r>
           </a:p>
-        </p:txBody>
-      </p:sp>
-      <p:sp>
-        <p:nvSpPr>
-          <p:cNvPr id="8" name="TextBox 7"/>
-          <p:cNvSpPr txBox="1"/>
-          <p:nvPr/>
-        </p:nvSpPr>
-        <p:spPr>
-          <a:xfrm>
-            <a:off x="6400800" y="1097280"/>
-            <a:ext cx="5303520" cy="457200"/>
-          </a:xfrm>
-          <a:prstGeom prst="rect">
-            <a:avLst/>
-          </a:prstGeom>
-          <a:noFill/>
-        </p:spPr>
-        <p:txBody>
-          <a:bodyPr wrap="square" anchor="t">
-            <a:spAutoFit/>
-          </a:bodyPr>
-          <a:lstStyle/>
-          <a:p>
-            <a:pPr algn="l">
-              <a:lnSpc>
-                <a:spcPct val="100000"/>
-              </a:lnSpc>
-            </a:pPr>
-            <a:r>
-              <a:rPr sz="1800" b="1">
-                <a:solidFill>
-                  <a:srgbClr val="0F3D5C"/>
-                </a:solidFill>
-                <a:latin typeface="Calibri"/>
-              </a:rPr>
-              <a:t>Ограничения</a:t>
-            </a:r>
-          </a:p>
-        </p:txBody>
-      </p:sp>
-      <p:sp>
-        <p:nvSpPr>
-          <p:cNvPr id="9" name="TextBox 8"/>
-          <p:cNvSpPr txBox="1"/>
-          <p:nvPr/>
-        </p:nvSpPr>
-        <p:spPr>
-          <a:xfrm>
-            <a:off x="6400800" y="1508760"/>
-            <a:ext cx="5303520" cy="4206240"/>
-          </a:xfrm>
-          <a:prstGeom prst="rect">
-            <a:avLst/>
-          </a:prstGeom>
-          <a:noFill/>
-        </p:spPr>
-        <p:txBody>
-          <a:bodyPr wrap="square" anchor="t">
-            <a:spAutoFit/>
-          </a:bodyPr>
-          <a:lstStyle/>
-          <a:p>
-            <a:pPr algn="l">
-              <a:lnSpc>
-                <a:spcPct val="100000"/>
-              </a:lnSpc>
-            </a:pPr>
-            <a:r>
-              <a:rPr sz="1400" b="0">
-                <a:solidFill>
-                  <a:srgbClr val="1F2A33"/>
-                </a:solidFill>
-                <a:latin typeface="Calibri"/>
-              </a:rPr>
-              <a:t/>
-            </a:r>
-          </a:p>
           <a:p>
             <a:pPr marL="260000" indent="-260000">
               <a:lnSpc>
@@ -6088,7 +6011,7 @@
                 </a:solidFill>
                 <a:latin typeface="Calibri"/>
               </a:rPr>
-              <a:t>•  HNSW не персистится на диск: старт процесса ~60–70 с (защита от chroma#7090)</a:t>
+              <a:t>•  0008: метаданные из XML — BM25 Hit@3 93,0 → 99,7 %</a:t>
             </a:r>
           </a:p>
           <a:p>
@@ -6110,7 +6033,85 @@
                 </a:solidFill>
                 <a:latin typeface="Calibri"/>
               </a:rPr>
-              <a:t>•  Gold-set частично синтетический, абсолютные метрики скромные</a:t>
+              <a:t>•  0009: смена корпуса — лидер hybrid → vector, зафиксировано</a:t>
+            </a:r>
+          </a:p>
+        </p:txBody>
+      </p:sp>
+      <p:sp>
+        <p:nvSpPr>
+          <p:cNvPr id="8" name="TextBox 7"/>
+          <p:cNvSpPr txBox="1"/>
+          <p:nvPr/>
+        </p:nvSpPr>
+        <p:spPr>
+          <a:xfrm>
+            <a:off x="6400800" y="1097280"/>
+            <a:ext cx="5303520" cy="457200"/>
+          </a:xfrm>
+          <a:prstGeom prst="rect">
+            <a:avLst/>
+          </a:prstGeom>
+          <a:noFill/>
+        </p:spPr>
+        <p:txBody>
+          <a:bodyPr wrap="square" anchor="t">
+            <a:spAutoFit/>
+          </a:bodyPr>
+          <a:lstStyle/>
+          <a:p>
+            <a:pPr algn="l">
+              <a:lnSpc>
+                <a:spcPct val="100000"/>
+              </a:lnSpc>
+            </a:pPr>
+            <a:r>
+              <a:rPr sz="1800" b="1">
+                <a:solidFill>
+                  <a:srgbClr val="0F3D5C"/>
+                </a:solidFill>
+                <a:latin typeface="Calibri"/>
+              </a:rPr>
+              <a:t>Ограничения</a:t>
+            </a:r>
+          </a:p>
+        </p:txBody>
+      </p:sp>
+      <p:sp>
+        <p:nvSpPr>
+          <p:cNvPr id="9" name="TextBox 8"/>
+          <p:cNvSpPr txBox="1"/>
+          <p:nvPr/>
+        </p:nvSpPr>
+        <p:spPr>
+          <a:xfrm>
+            <a:off x="6400800" y="1508760"/>
+            <a:ext cx="5303520" cy="4206240"/>
+          </a:xfrm>
+          <a:prstGeom prst="rect">
+            <a:avLst/>
+          </a:prstGeom>
+          <a:noFill/>
+        </p:spPr>
+        <p:txBody>
+          <a:bodyPr wrap="square" anchor="t">
+            <a:spAutoFit/>
+          </a:bodyPr>
+          <a:lstStyle/>
+          <a:p>
+            <a:pPr algn="l">
+              <a:lnSpc>
+                <a:spcPct val="100000"/>
+              </a:lnSpc>
+            </a:pPr>
+            <a:r>
+              <a:rPr sz="1400" b="0">
+                <a:solidFill>
+                  <a:srgbClr val="1F2A33"/>
+                </a:solidFill>
+                <a:latin typeface="Calibri"/>
+              </a:rPr>
+              <a:t/>
             </a:r>
           </a:p>
           <a:p>
@@ -6132,7 +6133,73 @@
                 </a:solidFill>
                 <a:latin typeface="Calibri"/>
               </a:rPr>
+              <a:t>•  HNSW не персистится на диск: старт процесса ~60–70 с (защита от chroma#7090)</a:t>
+            </a:r>
+          </a:p>
+          <a:p>
+            <a:pPr marL="260000" indent="-260000">
+              <a:lnSpc>
+                <a:spcPct val="100000"/>
+              </a:lnSpc>
+              <a:spcBef>
+                <a:spcPts val="600"/>
+              </a:spcBef>
+              <a:spcAft>
+                <a:spcPts val="400"/>
+              </a:spcAft>
+            </a:pPr>
+            <a:r>
+              <a:rPr sz="1400" b="0">
+                <a:solidFill>
+                  <a:srgbClr val="1F2A33"/>
+                </a:solidFill>
+                <a:latin typeface="Calibri"/>
+              </a:rPr>
+              <a:t>•  Gold-set частично синтетический, абсолютные метрики скромные</a:t>
+            </a:r>
+          </a:p>
+          <a:p>
+            <a:pPr marL="260000" indent="-260000">
+              <a:lnSpc>
+                <a:spcPct val="100000"/>
+              </a:lnSpc>
+              <a:spcBef>
+                <a:spcPts val="600"/>
+              </a:spcBef>
+              <a:spcAft>
+                <a:spcPts val="400"/>
+              </a:spcAft>
+            </a:pPr>
+            <a:r>
+              <a:rPr sz="1400" b="0">
+                <a:solidFill>
+                  <a:srgbClr val="1F2A33"/>
+                </a:solidFill>
+                <a:latin typeface="Calibri"/>
+              </a:rPr>
               <a:t>•  Один писатель индекса; параллельная индексация не поддерживается</a:t>
+            </a:r>
+          </a:p>
+          <a:p>
+            <a:pPr marL="260000" indent="-260000">
+              <a:lnSpc>
+                <a:spcPct val="100000"/>
+              </a:lnSpc>
+              <a:spcBef>
+                <a:spcPts val="600"/>
+              </a:spcBef>
+              <a:spcAft>
+                <a:spcPts val="400"/>
+              </a:spcAft>
+            </a:pPr>
+            <a:r>
+              <a:rPr sz="1400" b="0">
+                <a:solidFill>
+                  <a:srgbClr val="1F2A33"/>
+                </a:solidFill>
+                <a:latin typeface="Calibri"/>
+              </a:rPr>
+              <a:t>•  Нет инкрементальной индексации: полная пересборка — часы</a:t>
             </a:r>
           </a:p>
           <a:p>
@@ -6393,7 +6460,7 @@
                 </a:solidFill>
                 <a:latin typeface="Calibri"/>
               </a:rPr>
-              <a:t>•  MCP-сервер с 8 инструментами и локальным индексом на 124 тыс. чанков</a:t>
+              <a:t>•  MCP-сервер с 8 инструментами и локальным индексом на 179 тыс. чанков</a:t>
             </a:r>
           </a:p>
           <a:p>
@@ -6437,7 +6504,7 @@
                 </a:solidFill>
                 <a:latin typeface="Calibri"/>
               </a:rPr>
-              <a:t>•  Маршрутизация запросов: контракт с тестами, 100 % на размеченных кейсах</a:t>
+              <a:t>•  Маршрутизация: контракт с тестами, 68 кейсов + blind 20/20</a:t>
             </a:r>
           </a:p>
           <a:p>
@@ -6481,7 +6548,7 @@
                 </a:solidFill>
                 <a:latin typeface="Calibri"/>
               </a:rPr>
-              <a:t>•  Инженерная обвязка: 71 тест, ruff, mypy, complexity-гейт, CI, ADR, CHANGELOG</a:t>
+              <a:t>•  Инженерная обвязка: 72 теста, ruff, mypy, complexity-гейт, CI, ADR, CHANGELOG</a:t>
             </a:r>
           </a:p>
         </p:txBody>
@@ -6542,7 +6609,7 @@
                 </a:solidFill>
                 <a:latin typeface="Calibri"/>
               </a:rPr>
-              <a:t>•  Сравнить chunking по процедурам с текущим на gold-set v2; решить о смене дефолта</a:t>
+              <a:t>•  Ablation нарезок и веса RRF; затем смена дефолта на vector</a:t>
             </a:r>
           </a:p>
           <a:p>
@@ -6564,7 +6631,7 @@
                 </a:solidFill>
                 <a:latin typeface="Calibri"/>
               </a:rPr>
-              <a:t>•  Код-ориентированные эмбеддинги и новый baseline</a:t>
+              <a:t>•  Инкрементальная индексация и структурные инструменты (get_metadata, find_callers)</a:t>
             </a:r>
           </a:p>
           <a:p>
@@ -6586,7 +6653,7 @@
                 </a:solidFill>
                 <a:latin typeface="Calibri"/>
               </a:rPr>
-              <a:t>•  Reranker, предобученный на коде; ручная разметка 100+ запросов</a:t>
+              <a:t>•  Код-ориентированные эмбеддинги; reranker на коде; ручная разметка 100+ запросов</a:t>
             </a:r>
           </a:p>
         </p:txBody>
@@ -7035,7 +7102,7 @@
                 </a:solidFill>
                 <a:latin typeface="Calibri"/>
               </a:rPr>
-              <a:t>•  Гибридный поиск: cosine + глобальный BM25 через RRF</a:t>
+              <a:t>•  Гибридный поиск: cosine + BM25 через RRF; метаданные — из XML-выгрузки</a:t>
             </a:r>
           </a:p>
           <a:p>
@@ -7291,7 +7358,7 @@
                 </a:solidFill>
                 <a:latin typeface="Calibri"/>
               </a:rPr>
-              <a:t>124 253</a:t>
+              <a:t>179 586</a:t>
             </a:r>
           </a:p>
           <a:p>
@@ -7307,7 +7374,7 @@
                 </a:solidFill>
                 <a:latin typeface="Calibri"/>
               </a:rPr>
-              <a:t>чанка в индексе</a:t>
+              <a:t>чанков в индексе</a:t>
             </a:r>
           </a:p>
         </p:txBody>
@@ -7363,7 +7430,7 @@
                 </a:solidFill>
                 <a:latin typeface="Calibri"/>
               </a:rPr>
-              <a:t>233 515</a:t>
+              <a:t>0.339</a:t>
             </a:r>
           </a:p>
           <a:p>
@@ -7379,7 +7446,7 @@
                 </a:solidFill>
                 <a:latin typeface="Calibri"/>
               </a:rPr>
-              <a:t>термов в BM25</a:t>
+              <a:t>nDCG@10 у vector</a:t>
             </a:r>
           </a:p>
         </p:txBody>
@@ -7435,7 +7502,7 @@
                 </a:solidFill>
                 <a:latin typeface="Calibri"/>
               </a:rPr>
-              <a:t>0.209</a:t>
+              <a:t>68/68</a:t>
             </a:r>
           </a:p>
           <a:p>
@@ -7451,7 +7518,7 @@
                 </a:solidFill>
                 <a:latin typeface="Calibri"/>
               </a:rPr>
-              <a:t>nDCG@10 у hybrid</a:t>
+              <a:t>кейсов маршрутизации</a:t>
             </a:r>
           </a:p>
         </p:txBody>
@@ -7507,7 +7574,7 @@
                 </a:solidFill>
                 <a:latin typeface="Calibri"/>
               </a:rPr>
-              <a:t>71</a:t>
+              <a:t>99,7 %</a:t>
             </a:r>
           </a:p>
           <a:p>
@@ -7523,7 +7590,7 @@
                 </a:solidFill>
                 <a:latin typeface="Calibri"/>
               </a:rPr>
-              <a:t>unit-тест, CI зелёный</a:t>
+              <a:t>BM25 Hit@3 метаданных</a:t>
             </a:r>
           </a:p>
         </p:txBody>
@@ -9409,7 +9476,7 @@
                 </a:solidFill>
                 <a:latin typeface="Calibri"/>
               </a:rPr>
-              <a:t>•  124 253 чанка: code 100 445, metadata 23 808</a:t>
+              <a:t>•  179 586 чанков: code 154 560 (процедуры), metadata 25 026 (XML)</a:t>
             </a:r>
           </a:p>
           <a:p>
@@ -9453,7 +9520,7 @@
                 </a:solidFill>
                 <a:latin typeface="Calibri"/>
               </a:rPr>
-              <a:t>•  Проверка: 32,1 % чанков были длиннее лимита — исправляем нарезкой по процедурам</a:t>
+              <a:t>•  Проверка: 32,1 % чанков были длиннее лимита — исправлено нарезкой по процедурам (ADR 0007)</a:t>
             </a:r>
           </a:p>
           <a:p>
@@ -9619,7 +9686,7 @@
                 </a:solidFill>
                 <a:latin typeface="Calibri"/>
               </a:rPr>
-              <a:t>•  Инвертированный индекс: 233 515 термов, 6.1 млн постингов</a:t>
+              <a:t>•  Инвертированный индекс: 219 968 термов, 6,6 млн постингов</a:t>
             </a:r>
           </a:p>
           <a:p>
@@ -9641,7 +9708,7 @@
                 </a:solidFill>
                 <a:latin typeface="Calibri"/>
               </a:rPr>
-              <a:t>•  Сборка 9 с, 51 МБ на диске, читает документы прямо из sqlite</a:t>
+              <a:t>•  Сборка 22 с, 58 МБ на диске, читает документы прямо из sqlite</a:t>
             </a:r>
           </a:p>
           <a:p>
@@ -10085,7 +10152,7 @@
                           </a:solidFill>
                           <a:latin typeface="Calibri"/>
                         </a:rPr>
-                        <a:t>RRF: смешанные вопросы и требования — безопасный дефолт</a:t>
+                        <a:t>RRF: лучший для exact-имён; на новом корпусе vector впереди</a:t>
                       </a:r>
                     </a:p>
                   </a:txBody>
@@ -10155,7 +10222,7 @@
                           </a:solidFill>
                           <a:latin typeface="Calibri"/>
                         </a:rPr>
-                        <a:t>search / codesearch / evaluate_retrieval</a:t>
+                        <a:t>search / index_stats / evaluate_retrieval</a:t>
                       </a:r>
                     </a:p>
                   </a:txBody>
@@ -10177,7 +10244,7 @@
                           </a:solidFill>
                           <a:latin typeface="Calibri"/>
                         </a:rPr>
-                        <a:t>исторические инструменты и метрики по запросу</a:t>
+                        <a:t>поиск, состав индекса и метрики по запросу</a:t>
                       </a:r>
                     </a:p>
                   </a:txBody>
@@ -10270,7 +10337,7 @@
                 </a:solidFill>
                 <a:latin typeface="Calibri"/>
               </a:rPr>
-              <a:t>•  Маршрутизация — код с тестами, а не текст промпта: 24 кейса, 100 % точности</a:t>
+              <a:t>•  Маршрутизация — код с тестами: 68 кейсов, 100 %; blind 20/20 после правок</a:t>
             </a:r>
           </a:p>
           <a:p>
@@ -10697,7 +10764,7 @@
                 </a:solidFill>
                 <a:latin typeface="Calibri"/>
               </a:rPr>
-              <a:t>•  vector: 0.176 ± 0.005</a:t>
+              <a:t>•  Прежний корпус: hybrid 0.209 (+19 % к vector)</a:t>
             </a:r>
           </a:p>
           <a:p>
@@ -10715,11 +10782,11 @@
             <a:r>
               <a:rPr sz="1500" b="0">
                 <a:solidFill>
-                  <a:srgbClr val="2E7D4F"/>
-                </a:solidFill>
-                <a:latin typeface="Calibri"/>
-              </a:rPr>
-              <a:t>•  hybrid (RRF): 0.209 ± 0.003  →  +19 %</a:t>
+                  <a:srgbClr val="1F2A33"/>
+                </a:solidFill>
+                <a:latin typeface="Calibri"/>
+              </a:rPr>
+              <a:t>•  Новый корпус: vector 0.339, hybrid 0.301</a:t>
             </a:r>
           </a:p>
           <a:p>
@@ -10741,7 +10808,7 @@
                 </a:solidFill>
                 <a:latin typeface="Calibri"/>
               </a:rPr>
-              <a:t>•  Латентность: ~60 мс/запрос</a:t>
+              <a:t>•  Причина: процедурные чанки ослабили BM25 (ADR 0009)</a:t>
             </a:r>
           </a:p>
           <a:p>
@@ -10763,7 +10830,7 @@
                 </a:solidFill>
                 <a:latin typeface="Calibri"/>
               </a:rPr>
-              <a:t>•  Разброс ±0.003 — вывод устойчив к пересборке HNSW</a:t>
+              <a:t>•  Латентность: 50–120 мс/запрос</a:t>
             </a:r>
           </a:p>
         </p:txBody>
@@ -11183,7 +11250,7 @@
                 </a:solidFill>
                 <a:latin typeface="Calibri"/>
               </a:rPr>
-              <a:t>•  nDCG@10: 0.209 → 0.069 (−67 %)</a:t>
+              <a:t>•  nDCG@10: 0.301 → 0.117 (−61 %)</a:t>
             </a:r>
           </a:p>
           <a:p>
@@ -11205,7 +11272,7 @@
                 </a:solidFill>
                 <a:latin typeface="Calibri"/>
               </a:rPr>
-              <a:t>•  Латентность: ×18 медленнее hybrid</a:t>
+              <a:t>•  Латентность: ~2,4 с/запрос (×20 к vector)</a:t>
             </a:r>
           </a:p>
           <a:p>
@@ -11249,7 +11316,7 @@
                 </a:solidFill>
                 <a:latin typeface="Calibri"/>
               </a:rPr>
-              <a:t>•  Решение: режим оставлен опцией, дефолт — hybrid (ADR 0002)</a:t>
+              <a:t>•  Решение: режим оставлен опцией; дефолт пересматривается (ADR 0002, 0009)</a:t>
             </a:r>
           </a:p>
           <a:p>
@@ -11598,7 +11665,7 @@
                 </a:solidFill>
                 <a:latin typeface="Calibri"/>
               </a:rPr>
-              <a:t>•  Каждый прогон — новый процесс: HNSW пересобирается, поэтому mean ± std</a:t>
+              <a:t>•  Каждый прогон — новый процесс: HNSW пересобирается; 4 прогона, mean ± std</a:t>
             </a:r>
           </a:p>
         </p:txBody>
@@ -11725,7 +11792,7 @@
                 </a:solidFill>
                 <a:latin typeface="Calibri"/>
               </a:rPr>
-              <a:t>•  Разброс ±0.003 у hybrid — вывод воспроизводим, а не случайная удача</a:t>
+              <a:t>•  Разброс ±0.023 у vector — вывод воспроизводим, а не случайная удача</a:t>
             </a:r>
           </a:p>
         </p:txBody>

</xml_diff>

<commit_message>
docs: neutral public wording; align deck tool count
</commit_message>
<xml_diff>
--- a/docs/presentation/1c-mcp-rag-search-slides.pptx
+++ b/docs/presentation/1c-mcp-rag-search-slides.pptx
@@ -809,7 +809,7 @@
           <a:lstStyle/>
           <a:p>
             <a:r>
-              <a:t>Открытость про ограничения — плюс на защите: видно, что мы понимаем границы решения.</a:t>
+              <a:t>Открытость про ограничения — сильная сторона: видно, что мы понимаем границы решения.</a:t>
             </a:r>
           </a:p>
         </p:txBody>
@@ -1229,7 +1229,7 @@
           <a:lstStyle/>
           <a:p>
             <a:r>
-              <a:t>Восемь инструментов. Ключевое отличие от обычного MCP-сервера — явный контракт маршрутизации: выбор инструмента объясним и проверяется тестами.</a:t>
+              <a:t>Девять инструментов. Ключевое отличие от обычного MCP-сервера — явный контракт маршрутизации: выбор инструмента объясним и проверяется тестами.</a:t>
             </a:r>
           </a:p>
         </p:txBody>
@@ -6460,7 +6460,7 @@
                 </a:solidFill>
                 <a:latin typeface="Calibri"/>
               </a:rPr>
-              <a:t>•  MCP-сервер с 8 инструментами и локальным индексом на 179 тыс. чанков</a:t>
+              <a:t>•  MCP-сервер с 9 инструментами и локальным индексом на 179 тыс. чанков</a:t>
             </a:r>
           </a:p>
           <a:p>
@@ -7058,7 +7058,7 @@
                 </a:solidFill>
                 <a:latin typeface="Calibri"/>
               </a:rPr>
-              <a:t>•  Свой MCP-сервер (stdio): 8 инструментов, включая маршрутизацию запросов</a:t>
+              <a:t>•  Свой MCP-сервер (stdio): 9 инструментов, включая маршрутизацию запросов</a:t>
             </a:r>
           </a:p>
           <a:p>
@@ -7717,7 +7717,7 @@
                 </a:solidFill>
                 <a:latin typeface="Calibri"/>
               </a:rPr>
-              <a:t>•  Интерфейс: MCP stdio (Cursor / ZCode), 8 инструментов; eval: 70 запросов, 4 конфигурации</a:t>
+              <a:t>•  Интерфейс: MCP stdio (Cursor / ZCode), 9 инструментов; eval: 70 запросов, 4 конфигурации</a:t>
             </a:r>
           </a:p>
         </p:txBody>

</xml_diff>

<commit_message>
fix(bm25): split CamelCase identifiers and rebuild lexical index
CamelCase/snake_case splitting keeps the original token and adds parts, so natural queries match identifiers such as ZаказПокупателя. Rebuilt bm25_all: 179586 docs, 236320 terms, 81 MB.

v2 dev, 4 runs: hybrid 0.442 +/- 0.012 vs vector 0.331 +/- 0.028 (p=0.0037). v3 hold-out, 3 runs: hybrid 0.217 vs vector 0.208 (p=0.635). ADR 0009 rejected; ADR 0010 accepted; reports, README and decks updated.
</commit_message>
<xml_diff>
--- a/docs/presentation/1c-mcp-rag-search-slides.pptx
+++ b/docs/presentation/1c-mcp-rag-search-slides.pptx
@@ -188,13 +188,13 @@
                 <c:formatCode>General</c:formatCode>
                 <c:ptCount val="4"/>
                 <c:pt idx="0">
-                  <c:v>0.339</c:v>
+                  <c:v>0.331</c:v>
                 </c:pt>
                 <c:pt idx="1">
-                  <c:v>0.337</c:v>
+                  <c:v>0.383</c:v>
                 </c:pt>
                 <c:pt idx="2">
-                  <c:v>0.301</c:v>
+                  <c:v>0.442</c:v>
                 </c:pt>
                 <c:pt idx="3">
                   <c:v>0.117</c:v>
@@ -739,7 +739,7 @@
           <a:lstStyle/>
           <a:p>
             <a:r>
-              <a:t>Таблица и график по новому корпусу. Vector впереди; hybrid остаётся лучшим для exact-запросов; reranker проигрывает.</a:t>
+              <a:t>Таблица и график после фикса BM25. Hybrid впереди (0.442); paired-тест значим (p = 0.0037). Reranker проигрывает.</a:t>
             </a:r>
           </a:p>
         </p:txBody>
@@ -1019,7 +1019,7 @@
           <a:lstStyle/>
           <a:p>
             <a:r>
-              <a:t>Ключевые числа проекта: 179 586 чанков — 154 560 кода (процедурная нарезка) и 25 026 метаданных (XML). Лидер на новом корпусе — vector (ADR 0009).</a:t>
+              <a:t>Ключевые числа проекта: 179 586 чанков — 154 560 кода (процедурная нарезка) и 25 026 метаданных (XML). После фикса BM25 лидер — hybrid 0.442 (ADR 0010).</a:t>
             </a:r>
           </a:p>
         </p:txBody>
@@ -1299,7 +1299,7 @@
           <a:lstStyle/>
           <a:p>
             <a:r>
-              <a:t>RRF — центральное решение проекта. Складываем не скоры, а позиции; поэтому не нужно подбирать веса. На прежнем корпусе прирост был +19 %, на новом лидер сменился — это зафиксировано в ADR 0009.</a:t>
+              <a:t>RRF — центральное решение проекта. Складываем не скоры, а позиции; поэтому не нужно подбирать веса. На прежнем корпусе прирост был +19 %; «смена лидера» оказалась дефектом BM25 и отклонена (ADR 0010).</a:t>
             </a:r>
           </a:p>
         </p:txBody>
@@ -4893,7 +4893,7 @@
                 <a:gridCol w="1811793"/>
                 <a:gridCol w="1733019"/>
               </a:tblGrid>
-              <a:tr h="429768">
+              <a:tr h="358140">
                 <a:tc>
                   <a:txBody>
                     <a:bodyPr/>
@@ -5027,7 +5027,7 @@
                   </a:tcPr>
                 </a:tc>
               </a:tr>
-              <a:tr h="429768">
+              <a:tr h="358140">
                 <a:tc>
                   <a:txBody>
                     <a:bodyPr/>
@@ -5062,7 +5062,7 @@
                           </a:solidFill>
                           <a:latin typeface="Calibri"/>
                         </a:rPr>
-                        <a:t>0.150 ± 0.007</a:t>
+                        <a:t>0.157 ± 0.018</a:t>
                       </a:r>
                     </a:p>
                   </a:txBody>
@@ -5084,7 +5084,7 @@
                           </a:solidFill>
                           <a:latin typeface="Calibri"/>
                         </a:rPr>
-                        <a:t>0.268 ± 0.019</a:t>
+                        <a:t>0.266 ± 0.026</a:t>
                       </a:r>
                     </a:p>
                   </a:txBody>
@@ -5106,7 +5106,7 @@
                           </a:solidFill>
                           <a:latin typeface="Calibri"/>
                         </a:rPr>
-                        <a:t>0.339 ± 0.023</a:t>
+                        <a:t>0.331 ± 0.028</a:t>
                       </a:r>
                     </a:p>
                   </a:txBody>
@@ -5128,7 +5128,7 @@
                           </a:solidFill>
                           <a:latin typeface="Calibri"/>
                         </a:rPr>
-                        <a:t>0.523 ± 0.030</a:t>
+                        <a:t>0.511 ± 0.044</a:t>
                       </a:r>
                     </a:p>
                   </a:txBody>
@@ -5161,7 +5161,7 @@
                   </a:tcPr>
                 </a:tc>
               </a:tr>
-              <a:tr h="429768">
+              <a:tr h="358140">
                 <a:tc>
                   <a:txBody>
                     <a:bodyPr/>
@@ -5196,7 +5196,7 @@
                           </a:solidFill>
                           <a:latin typeface="Calibri"/>
                         </a:rPr>
-                        <a:t>0.179 ± 0.021</a:t>
+                        <a:t>0.207 ± 0.038</a:t>
                       </a:r>
                     </a:p>
                   </a:txBody>
@@ -5218,7 +5218,7 @@
                           </a:solidFill>
                           <a:latin typeface="Calibri"/>
                         </a:rPr>
-                        <a:t>0.270 ± 0.024</a:t>
+                        <a:t>0.313 ± 0.039</a:t>
                       </a:r>
                     </a:p>
                   </a:txBody>
@@ -5240,7 +5240,7 @@
                           </a:solidFill>
                           <a:latin typeface="Calibri"/>
                         </a:rPr>
-                        <a:t>0.337 ± 0.030</a:t>
+                        <a:t>0.383 ± 0.040</a:t>
                       </a:r>
                     </a:p>
                   </a:txBody>
@@ -5262,7 +5262,7 @@
                           </a:solidFill>
                           <a:latin typeface="Calibri"/>
                         </a:rPr>
-                        <a:t>0.511 ± 0.048</a:t>
+                        <a:t>0.562 ± 0.053</a:t>
                       </a:r>
                     </a:p>
                   </a:txBody>
@@ -5295,7 +5295,7 @@
                   </a:tcPr>
                 </a:tc>
               </a:tr>
-              <a:tr h="429768">
+              <a:tr h="358140">
                 <a:tc>
                   <a:txBody>
                     <a:bodyPr/>
@@ -5330,7 +5330,7 @@
                           </a:solidFill>
                           <a:latin typeface="Calibri"/>
                         </a:rPr>
-                        <a:t>0.129 ± 0.010</a:t>
+                        <a:t>0.221 ± 0.008</a:t>
                       </a:r>
                     </a:p>
                   </a:txBody>
@@ -5352,7 +5352,7 @@
                           </a:solidFill>
                           <a:latin typeface="Calibri"/>
                         </a:rPr>
-                        <a:t>0.240 ± 0.013</a:t>
+                        <a:t>0.368 ± 0.010</a:t>
                       </a:r>
                     </a:p>
                   </a:txBody>
@@ -5374,7 +5374,7 @@
                           </a:solidFill>
                           <a:latin typeface="Calibri"/>
                         </a:rPr>
-                        <a:t>0.301 ± 0.017</a:t>
+                        <a:t>0.442 ± 0.012</a:t>
                       </a:r>
                     </a:p>
                   </a:txBody>
@@ -5396,7 +5396,7 @@
                           </a:solidFill>
                           <a:latin typeface="Calibri"/>
                         </a:rPr>
-                        <a:t>0.482 ± 0.034</a:t>
+                        <a:t>0.652 ± 0.024</a:t>
                       </a:r>
                     </a:p>
                   </a:txBody>
@@ -5429,7 +5429,7 @@
                   </a:tcPr>
                 </a:tc>
               </a:tr>
-              <a:tr h="429768">
+              <a:tr h="358140">
                 <a:tc>
                   <a:txBody>
                     <a:bodyPr/>
@@ -5442,7 +5442,7 @@
                           </a:solidFill>
                           <a:latin typeface="Calibri"/>
                         </a:rPr>
-                        <a:t>hybrid_rerank</a:t>
+                        <a:t>lexical (BM25)</a:t>
                       </a:r>
                     </a:p>
                   </a:txBody>
@@ -5464,7 +5464,7 @@
                           </a:solidFill>
                           <a:latin typeface="Calibri"/>
                         </a:rPr>
-                        <a:t>0.086</a:t>
+                        <a:t>0.271</a:t>
                       </a:r>
                     </a:p>
                   </a:txBody>
@@ -5486,7 +5486,7 @@
                           </a:solidFill>
                           <a:latin typeface="Calibri"/>
                         </a:rPr>
-                        <a:t>0.102</a:t>
+                        <a:t>0.355</a:t>
                       </a:r>
                     </a:p>
                   </a:txBody>
@@ -5508,7 +5508,7 @@
                           </a:solidFill>
                           <a:latin typeface="Calibri"/>
                         </a:rPr>
-                        <a:t>0.117</a:t>
+                        <a:t>0.426</a:t>
                       </a:r>
                     </a:p>
                   </a:txBody>
@@ -5530,7 +5530,7 @@
                           </a:solidFill>
                           <a:latin typeface="Calibri"/>
                         </a:rPr>
-                        <a:t>0.157</a:t>
+                        <a:t>0.571</a:t>
                       </a:r>
                     </a:p>
                   </a:txBody>
@@ -5552,13 +5552,147 @@
                           </a:solidFill>
                           <a:latin typeface="Calibri"/>
                         </a:rPr>
+                        <a:t>~20</a:t>
+                      </a:r>
+                    </a:p>
+                  </a:txBody>
+                  <a:tcPr anchor="ctr">
+                    <a:solidFill>
+                      <a:srgbClr val="EAF2F7"/>
+                    </a:solidFill>
+                  </a:tcPr>
+                </a:tc>
+              </a:tr>
+              <a:tr h="358140">
+                <a:tc>
+                  <a:txBody>
+                    <a:bodyPr/>
+                    <a:lstStyle/>
+                    <a:p>
+                      <a:r>
+                        <a:rPr sz="1200" b="0">
+                          <a:solidFill>
+                            <a:srgbClr val="1F2A33"/>
+                          </a:solidFill>
+                          <a:latin typeface="Calibri"/>
+                        </a:rPr>
+                        <a:t>hybrid_rerank</a:t>
+                      </a:r>
+                    </a:p>
+                  </a:txBody>
+                  <a:tcPr anchor="ctr">
+                    <a:solidFill>
+                      <a:srgbClr val="FFFFFF"/>
+                    </a:solidFill>
+                  </a:tcPr>
+                </a:tc>
+                <a:tc>
+                  <a:txBody>
+                    <a:bodyPr/>
+                    <a:lstStyle/>
+                    <a:p>
+                      <a:r>
+                        <a:rPr sz="1200" b="0">
+                          <a:solidFill>
+                            <a:srgbClr val="1F2A33"/>
+                          </a:solidFill>
+                          <a:latin typeface="Calibri"/>
+                        </a:rPr>
+                        <a:t>0.086</a:t>
+                      </a:r>
+                    </a:p>
+                  </a:txBody>
+                  <a:tcPr anchor="ctr">
+                    <a:solidFill>
+                      <a:srgbClr val="FFFFFF"/>
+                    </a:solidFill>
+                  </a:tcPr>
+                </a:tc>
+                <a:tc>
+                  <a:txBody>
+                    <a:bodyPr/>
+                    <a:lstStyle/>
+                    <a:p>
+                      <a:r>
+                        <a:rPr sz="1200" b="0">
+                          <a:solidFill>
+                            <a:srgbClr val="1F2A33"/>
+                          </a:solidFill>
+                          <a:latin typeface="Calibri"/>
+                        </a:rPr>
+                        <a:t>0.102</a:t>
+                      </a:r>
+                    </a:p>
+                  </a:txBody>
+                  <a:tcPr anchor="ctr">
+                    <a:solidFill>
+                      <a:srgbClr val="FFFFFF"/>
+                    </a:solidFill>
+                  </a:tcPr>
+                </a:tc>
+                <a:tc>
+                  <a:txBody>
+                    <a:bodyPr/>
+                    <a:lstStyle/>
+                    <a:p>
+                      <a:r>
+                        <a:rPr sz="1200" b="0">
+                          <a:solidFill>
+                            <a:srgbClr val="1F2A33"/>
+                          </a:solidFill>
+                          <a:latin typeface="Calibri"/>
+                        </a:rPr>
+                        <a:t>0.117</a:t>
+                      </a:r>
+                    </a:p>
+                  </a:txBody>
+                  <a:tcPr anchor="ctr">
+                    <a:solidFill>
+                      <a:srgbClr val="FFFFFF"/>
+                    </a:solidFill>
+                  </a:tcPr>
+                </a:tc>
+                <a:tc>
+                  <a:txBody>
+                    <a:bodyPr/>
+                    <a:lstStyle/>
+                    <a:p>
+                      <a:r>
+                        <a:rPr sz="1200" b="0">
+                          <a:solidFill>
+                            <a:srgbClr val="1F2A33"/>
+                          </a:solidFill>
+                          <a:latin typeface="Calibri"/>
+                        </a:rPr>
+                        <a:t>0.157</a:t>
+                      </a:r>
+                    </a:p>
+                  </a:txBody>
+                  <a:tcPr anchor="ctr">
+                    <a:solidFill>
+                      <a:srgbClr val="FFFFFF"/>
+                    </a:solidFill>
+                  </a:tcPr>
+                </a:tc>
+                <a:tc>
+                  <a:txBody>
+                    <a:bodyPr/>
+                    <a:lstStyle/>
+                    <a:p>
+                      <a:r>
+                        <a:rPr sz="1200" b="0">
+                          <a:solidFill>
+                            <a:srgbClr val="1F2A33"/>
+                          </a:solidFill>
+                          <a:latin typeface="Calibri"/>
+                        </a:rPr>
                         <a:t>~2400</a:t>
                       </a:r>
                     </a:p>
                   </a:txBody>
                   <a:tcPr anchor="ctr">
                     <a:solidFill>
-                      <a:srgbClr val="EAF2F7"/>
+                      <a:srgbClr val="FFFFFF"/>
                     </a:solidFill>
                   </a:tcPr>
                 </a:tc>
@@ -5620,9 +5754,9 @@
                 <a:latin typeface="Calibri"/>
               </a:rPr>
               <a:t>Источник: data/eval/code_proc/report_pipeline.md
-vector — лидер на новом корпусе.
-hybrid лучший для exact-имён
-(0.408 против 0.250 по nDCG@10).
+hybrid — лидер после фикса BM25.
+Paired vector−hybrid: Δ −0.112,
+p = 0.0037.
 Reranker ухудшает качество.</a:t>
             </a:r>
           </a:p>
@@ -5895,7 +6029,7 @@
               </a:spcAft>
             </a:pPr>
             <a:r>
-              <a:rPr sz="1400" b="0">
+              <a:rPr sz="1300" b="0">
                 <a:solidFill>
                   <a:srgbClr val="1F2A33"/>
                 </a:solidFill>
@@ -5917,7 +6051,7 @@
               </a:spcAft>
             </a:pPr>
             <a:r>
-              <a:rPr sz="1400" b="0">
+              <a:rPr sz="1300" b="0">
                 <a:solidFill>
                   <a:srgbClr val="1F2A33"/>
                 </a:solidFill>
@@ -5939,7 +6073,7 @@
               </a:spcAft>
             </a:pPr>
             <a:r>
-              <a:rPr sz="1400" b="0">
+              <a:rPr sz="1300" b="0">
                 <a:solidFill>
                   <a:srgbClr val="1F2A33"/>
                 </a:solidFill>
@@ -5961,7 +6095,7 @@
               </a:spcAft>
             </a:pPr>
             <a:r>
-              <a:rPr sz="1400" b="0">
+              <a:rPr sz="1300" b="0">
                 <a:solidFill>
                   <a:srgbClr val="1F2A33"/>
                 </a:solidFill>
@@ -5983,7 +6117,7 @@
               </a:spcAft>
             </a:pPr>
             <a:r>
-              <a:rPr sz="1400" b="0">
+              <a:rPr sz="1300" b="0">
                 <a:solidFill>
                   <a:srgbClr val="1F2A33"/>
                 </a:solidFill>
@@ -6005,7 +6139,7 @@
               </a:spcAft>
             </a:pPr>
             <a:r>
-              <a:rPr sz="1400" b="0">
+              <a:rPr sz="1300" b="0">
                 <a:solidFill>
                   <a:srgbClr val="1F2A33"/>
                 </a:solidFill>
@@ -6027,91 +6161,13 @@
               </a:spcAft>
             </a:pPr>
             <a:r>
-              <a:rPr sz="1400" b="0">
+              <a:rPr sz="1300" b="0">
                 <a:solidFill>
                   <a:srgbClr val="1F2A33"/>
                 </a:solidFill>
                 <a:latin typeface="Calibri"/>
               </a:rPr>
-              <a:t>•  0009: смена корпуса — лидер hybrid → vector, зафиксировано</a:t>
-            </a:r>
-          </a:p>
-        </p:txBody>
-      </p:sp>
-      <p:sp>
-        <p:nvSpPr>
-          <p:cNvPr id="8" name="TextBox 7"/>
-          <p:cNvSpPr txBox="1"/>
-          <p:nvPr/>
-        </p:nvSpPr>
-        <p:spPr>
-          <a:xfrm>
-            <a:off x="6400800" y="1097280"/>
-            <a:ext cx="5303520" cy="457200"/>
-          </a:xfrm>
-          <a:prstGeom prst="rect">
-            <a:avLst/>
-          </a:prstGeom>
-          <a:noFill/>
-        </p:spPr>
-        <p:txBody>
-          <a:bodyPr wrap="square" anchor="t">
-            <a:spAutoFit/>
-          </a:bodyPr>
-          <a:lstStyle/>
-          <a:p>
-            <a:pPr algn="l">
-              <a:lnSpc>
-                <a:spcPct val="100000"/>
-              </a:lnSpc>
-            </a:pPr>
-            <a:r>
-              <a:rPr sz="1800" b="1">
-                <a:solidFill>
-                  <a:srgbClr val="0F3D5C"/>
-                </a:solidFill>
-                <a:latin typeface="Calibri"/>
-              </a:rPr>
-              <a:t>Ограничения</a:t>
-            </a:r>
-          </a:p>
-        </p:txBody>
-      </p:sp>
-      <p:sp>
-        <p:nvSpPr>
-          <p:cNvPr id="9" name="TextBox 8"/>
-          <p:cNvSpPr txBox="1"/>
-          <p:nvPr/>
-        </p:nvSpPr>
-        <p:spPr>
-          <a:xfrm>
-            <a:off x="6400800" y="1508760"/>
-            <a:ext cx="5303520" cy="4206240"/>
-          </a:xfrm>
-          <a:prstGeom prst="rect">
-            <a:avLst/>
-          </a:prstGeom>
-          <a:noFill/>
-        </p:spPr>
-        <p:txBody>
-          <a:bodyPr wrap="square" anchor="t">
-            <a:spAutoFit/>
-          </a:bodyPr>
-          <a:lstStyle/>
-          <a:p>
-            <a:pPr algn="l">
-              <a:lnSpc>
-                <a:spcPct val="100000"/>
-              </a:lnSpc>
-            </a:pPr>
-            <a:r>
-              <a:rPr sz="1400" b="0">
-                <a:solidFill>
-                  <a:srgbClr val="1F2A33"/>
-                </a:solidFill>
-                <a:latin typeface="Calibri"/>
-              </a:rPr>
-              <a:t/>
+              <a:t>•  0009: смена корпуса — отклонена: дефект BM25-токенизатора</a:t>
             </a:r>
           </a:p>
           <a:p>
@@ -6127,13 +6183,91 @@
               </a:spcAft>
             </a:pPr>
             <a:r>
+              <a:rPr sz="1300" b="0">
+                <a:solidFill>
+                  <a:srgbClr val="1F2A33"/>
+                </a:solidFill>
+                <a:latin typeface="Calibri"/>
+              </a:rPr>
+              <a:t>•  0010: CamelCase-aware BM25 — hybrid снова лидер (0.442 против 0.331)</a:t>
+            </a:r>
+          </a:p>
+        </p:txBody>
+      </p:sp>
+      <p:sp>
+        <p:nvSpPr>
+          <p:cNvPr id="8" name="TextBox 7"/>
+          <p:cNvSpPr txBox="1"/>
+          <p:nvPr/>
+        </p:nvSpPr>
+        <p:spPr>
+          <a:xfrm>
+            <a:off x="6400800" y="1097280"/>
+            <a:ext cx="5303520" cy="457200"/>
+          </a:xfrm>
+          <a:prstGeom prst="rect">
+            <a:avLst/>
+          </a:prstGeom>
+          <a:noFill/>
+        </p:spPr>
+        <p:txBody>
+          <a:bodyPr wrap="square" anchor="t">
+            <a:spAutoFit/>
+          </a:bodyPr>
+          <a:lstStyle/>
+          <a:p>
+            <a:pPr algn="l">
+              <a:lnSpc>
+                <a:spcPct val="100000"/>
+              </a:lnSpc>
+            </a:pPr>
+            <a:r>
+              <a:rPr sz="1800" b="1">
+                <a:solidFill>
+                  <a:srgbClr val="0F3D5C"/>
+                </a:solidFill>
+                <a:latin typeface="Calibri"/>
+              </a:rPr>
+              <a:t>Ограничения</a:t>
+            </a:r>
+          </a:p>
+        </p:txBody>
+      </p:sp>
+      <p:sp>
+        <p:nvSpPr>
+          <p:cNvPr id="9" name="TextBox 8"/>
+          <p:cNvSpPr txBox="1"/>
+          <p:nvPr/>
+        </p:nvSpPr>
+        <p:spPr>
+          <a:xfrm>
+            <a:off x="6400800" y="1508760"/>
+            <a:ext cx="5303520" cy="4206240"/>
+          </a:xfrm>
+          <a:prstGeom prst="rect">
+            <a:avLst/>
+          </a:prstGeom>
+          <a:noFill/>
+        </p:spPr>
+        <p:txBody>
+          <a:bodyPr wrap="square" anchor="t">
+            <a:spAutoFit/>
+          </a:bodyPr>
+          <a:lstStyle/>
+          <a:p>
+            <a:pPr algn="l">
+              <a:lnSpc>
+                <a:spcPct val="100000"/>
+              </a:lnSpc>
+            </a:pPr>
+            <a:r>
               <a:rPr sz="1400" b="0">
                 <a:solidFill>
                   <a:srgbClr val="1F2A33"/>
                 </a:solidFill>
                 <a:latin typeface="Calibri"/>
               </a:rPr>
-              <a:t>•  HNSW не персистится на диск: старт процесса ~60–70 с (защита от chroma#7090)</a:t>
+              <a:t/>
             </a:r>
           </a:p>
           <a:p>
@@ -6149,13 +6283,13 @@
               </a:spcAft>
             </a:pPr>
             <a:r>
-              <a:rPr sz="1400" b="0">
+              <a:rPr sz="1300" b="0">
                 <a:solidFill>
                   <a:srgbClr val="1F2A33"/>
                 </a:solidFill>
                 <a:latin typeface="Calibri"/>
               </a:rPr>
-              <a:t>•  Gold-set частично синтетический, абсолютные метрики скромные</a:t>
+              <a:t>•  HNSW не персистится на диск: старт процесса ~60–70 с (защита от chroma#7090)</a:t>
             </a:r>
           </a:p>
           <a:p>
@@ -6171,13 +6305,13 @@
               </a:spcAft>
             </a:pPr>
             <a:r>
-              <a:rPr sz="1400" b="0">
+              <a:rPr sz="1300" b="0">
                 <a:solidFill>
                   <a:srgbClr val="1F2A33"/>
                 </a:solidFill>
                 <a:latin typeface="Calibri"/>
               </a:rPr>
-              <a:t>•  Один писатель индекса; параллельная индексация не поддерживается</a:t>
+              <a:t>•  Gold-set частично синтетический, абсолютные метрики скромные</a:t>
             </a:r>
           </a:p>
           <a:p>
@@ -6193,13 +6327,13 @@
               </a:spcAft>
             </a:pPr>
             <a:r>
-              <a:rPr sz="1400" b="0">
+              <a:rPr sz="1300" b="0">
                 <a:solidFill>
                   <a:srgbClr val="1F2A33"/>
                 </a:solidFill>
                 <a:latin typeface="Calibri"/>
               </a:rPr>
-              <a:t>•  Нет инкрементальной индексации: полная пересборка — часы</a:t>
+              <a:t>•  Один писатель индекса; параллельная индексация не поддерживается</a:t>
             </a:r>
           </a:p>
           <a:p>
@@ -6215,13 +6349,57 @@
               </a:spcAft>
             </a:pPr>
             <a:r>
-              <a:rPr sz="1400" b="0">
+              <a:rPr sz="1300" b="0">
                 <a:solidFill>
                   <a:srgbClr val="1F2A33"/>
                 </a:solidFill>
                 <a:latin typeface="Calibri"/>
               </a:rPr>
+              <a:t>•  Нет инкрементальной индексации: полная пересборка — часы</a:t>
+            </a:r>
+          </a:p>
+          <a:p>
+            <a:pPr marL="260000" indent="-260000">
+              <a:lnSpc>
+                <a:spcPct val="100000"/>
+              </a:lnSpc>
+              <a:spcBef>
+                <a:spcPts val="600"/>
+              </a:spcBef>
+              <a:spcAft>
+                <a:spcPts val="400"/>
+              </a:spcAft>
+            </a:pPr>
+            <a:r>
+              <a:rPr sz="1300" b="0">
+                <a:solidFill>
+                  <a:srgbClr val="1F2A33"/>
+                </a:solidFill>
+                <a:latin typeface="Calibri"/>
+              </a:rPr>
               <a:t>•  Reranker для кода — следующий контур (модель на коде или fine-tune)</a:t>
+            </a:r>
+          </a:p>
+          <a:p>
+            <a:pPr marL="260000" indent="-260000">
+              <a:lnSpc>
+                <a:spcPct val="100000"/>
+              </a:lnSpc>
+              <a:spcBef>
+                <a:spcPts val="600"/>
+              </a:spcBef>
+              <a:spcAft>
+                <a:spcPts val="400"/>
+              </a:spcAft>
+            </a:pPr>
+            <a:r>
+              <a:rPr sz="1300" b="0">
+                <a:solidFill>
+                  <a:srgbClr val="1F2A33"/>
+                </a:solidFill>
+                <a:latin typeface="Calibri"/>
+              </a:rPr>
+              <a:t>•  v3 hold-out: роутер 58/100; quoted-name кейсы уходят в hybrid</a:t>
             </a:r>
           </a:p>
         </p:txBody>
@@ -6548,7 +6726,7 @@
                 </a:solidFill>
                 <a:latin typeface="Calibri"/>
               </a:rPr>
-              <a:t>•  Инженерная обвязка: 72 теста, ruff, mypy, complexity-гейт, CI, ADR, CHANGELOG</a:t>
+              <a:t>•  Инженерная обвязка: 74 теста, ruff, mypy, complexity-гейт, CI, ADR, CHANGELOG</a:t>
             </a:r>
           </a:p>
         </p:txBody>
@@ -6609,7 +6787,7 @@
                 </a:solidFill>
                 <a:latin typeface="Calibri"/>
               </a:rPr>
-              <a:t>•  Ablation нарезок и веса RRF; затем смена дефолта на vector</a:t>
+              <a:t>•  Перезамерить symbolic/metadata исправленным BM25; проверить веса RRF</a:t>
             </a:r>
           </a:p>
           <a:p>
@@ -7430,7 +7608,7 @@
                 </a:solidFill>
                 <a:latin typeface="Calibri"/>
               </a:rPr>
-              <a:t>0.339</a:t>
+              <a:t>0.442</a:t>
             </a:r>
           </a:p>
           <a:p>
@@ -7446,7 +7624,7 @@
                 </a:solidFill>
                 <a:latin typeface="Calibri"/>
               </a:rPr>
-              <a:t>nDCG@10 у vector</a:t>
+              <a:t>nDCG@10 у hybrid</a:t>
             </a:r>
           </a:p>
         </p:txBody>
@@ -10786,7 +10964,7 @@
                 </a:solidFill>
                 <a:latin typeface="Calibri"/>
               </a:rPr>
-              <a:t>•  Новый корпус: vector 0.339, hybrid 0.301</a:t>
+              <a:t>•  Новый корпус после фикса BM25: hybrid 0.442, vector 0.331</a:t>
             </a:r>
           </a:p>
           <a:p>
@@ -10808,7 +10986,7 @@
                 </a:solidFill>
                 <a:latin typeface="Calibri"/>
               </a:rPr>
-              <a:t>•  Причина: процедурные чанки ослабили BM25 (ADR 0009)</a:t>
+              <a:t>•  Причина прежнего «сдвига» — CamelCase-дефект токенизатора (ADR 0010)</a:t>
             </a:r>
           </a:p>
           <a:p>
@@ -11250,7 +11428,7 @@
                 </a:solidFill>
                 <a:latin typeface="Calibri"/>
               </a:rPr>
-              <a:t>•  nDCG@10: 0.301 → 0.117 (−61 %)</a:t>
+              <a:t>•  nDCG@10: 0.117 против 0.301 (замер до фикса BM25; не перезамерялся)</a:t>
             </a:r>
           </a:p>
           <a:p>

</xml_diff>